<commit_message>
VOIS Major Project Completion
</commit_message>
<xml_diff>
--- a/VOIS_Major_Project_PPT_Submission_Template.pptx
+++ b/VOIS_Major_Project_PPT_Submission_Template.pptx
@@ -163,7 +163,7 @@
 <file path=ppt/revisionInfo.xml><?xml version="1.0" encoding="utf-8"?>
 <p1510:revInfo xmlns:a="http://schemas.openxmlformats.org/drawingml/2006/main" xmlns:r="http://schemas.openxmlformats.org/officeDocument/2006/relationships" xmlns:p1510="http://schemas.microsoft.com/office/powerpoint/2015/10/main">
   <p1510:revLst>
-    <p1510:client id="{ABEE10E6-4371-4621-B13F-38CDCD242604}" v="141" dt="2026-09-10T17:13:12.538"/>
+    <p1510:client id="{ABEE10E6-4371-4621-B13F-38CDCD242604}" v="142" dt="2026-09-10T18:08:02.839"/>
   </p1510:revLst>
 </p1510:revInfo>
 </file>
@@ -173,7 +173,7 @@
   <pc:docChgLst>
     <pc:chgData name="Chennuboyina Siva Sruthi" userId="757dd6f6081b8728" providerId="LiveId" clId="{88ED0A32-7A4F-4E9F-9492-1FFBEDFADE5C}"/>
     <pc:docChg chg="custSel modSld">
-      <pc:chgData name="Chennuboyina Siva Sruthi" userId="757dd6f6081b8728" providerId="LiveId" clId="{88ED0A32-7A4F-4E9F-9492-1FFBEDFADE5C}" dt="2026-09-10T17:31:53.451" v="323" actId="14100"/>
+      <pc:chgData name="Chennuboyina Siva Sruthi" userId="757dd6f6081b8728" providerId="LiveId" clId="{88ED0A32-7A4F-4E9F-9492-1FFBEDFADE5C}" dt="2026-09-10T18:10:08.595" v="358" actId="20577"/>
       <pc:docMkLst>
         <pc:docMk/>
       </pc:docMkLst>
@@ -189,6 +189,21 @@
             <pc:docMk/>
             <pc:sldMk cId="1341901065" sldId="302"/>
             <ac:spMk id="7" creationId="{B21C28F5-3CA3-4B78-B5C9-550C00BB3174}"/>
+          </ac:spMkLst>
+        </pc:spChg>
+      </pc:sldChg>
+      <pc:sldChg chg="modSp mod">
+        <pc:chgData name="Chennuboyina Siva Sruthi" userId="757dd6f6081b8728" providerId="LiveId" clId="{88ED0A32-7A4F-4E9F-9492-1FFBEDFADE5C}" dt="2026-09-10T18:09:12.875" v="355" actId="20577"/>
+        <pc:sldMkLst>
+          <pc:docMk/>
+          <pc:sldMk cId="3401748718" sldId="304"/>
+        </pc:sldMkLst>
+        <pc:spChg chg="mod">
+          <ac:chgData name="Chennuboyina Siva Sruthi" userId="757dd6f6081b8728" providerId="LiveId" clId="{88ED0A32-7A4F-4E9F-9492-1FFBEDFADE5C}" dt="2026-09-10T18:09:12.875" v="355" actId="20577"/>
+          <ac:spMkLst>
+            <pc:docMk/>
+            <pc:sldMk cId="3401748718" sldId="304"/>
+            <ac:spMk id="12" creationId="{BC277FD7-925B-4C3D-A364-118403201507}"/>
           </ac:spMkLst>
         </pc:spChg>
       </pc:sldChg>
@@ -231,7 +246,7 @@
         </pc:spChg>
       </pc:sldChg>
       <pc:sldChg chg="modSp mod">
-        <pc:chgData name="Chennuboyina Siva Sruthi" userId="757dd6f6081b8728" providerId="LiveId" clId="{88ED0A32-7A4F-4E9F-9492-1FFBEDFADE5C}" dt="2026-09-10T17:10:55.538" v="194" actId="14100"/>
+        <pc:chgData name="Chennuboyina Siva Sruthi" userId="757dd6f6081b8728" providerId="LiveId" clId="{88ED0A32-7A4F-4E9F-9492-1FFBEDFADE5C}" dt="2026-09-10T18:10:08.595" v="358" actId="20577"/>
         <pc:sldMkLst>
           <pc:docMk/>
           <pc:sldMk cId="1604013440" sldId="338"/>
@@ -245,7 +260,7 @@
           </ac:spMkLst>
         </pc:spChg>
         <pc:spChg chg="mod">
-          <ac:chgData name="Chennuboyina Siva Sruthi" userId="757dd6f6081b8728" providerId="LiveId" clId="{88ED0A32-7A4F-4E9F-9492-1FFBEDFADE5C}" dt="2026-09-10T17:10:55.538" v="194" actId="14100"/>
+          <ac:chgData name="Chennuboyina Siva Sruthi" userId="757dd6f6081b8728" providerId="LiveId" clId="{88ED0A32-7A4F-4E9F-9492-1FFBEDFADE5C}" dt="2026-09-10T18:10:08.595" v="358" actId="20577"/>
           <ac:spMkLst>
             <pc:docMk/>
             <pc:sldMk cId="1604013440" sldId="338"/>
@@ -254,7 +269,7 @@
         </pc:spChg>
       </pc:sldChg>
       <pc:sldChg chg="addSp modSp mod">
-        <pc:chgData name="Chennuboyina Siva Sruthi" userId="757dd6f6081b8728" providerId="LiveId" clId="{88ED0A32-7A4F-4E9F-9492-1FFBEDFADE5C}" dt="2026-09-10T17:26:54.607" v="292" actId="1076"/>
+        <pc:chgData name="Chennuboyina Siva Sruthi" userId="757dd6f6081b8728" providerId="LiveId" clId="{88ED0A32-7A4F-4E9F-9492-1FFBEDFADE5C}" dt="2026-09-10T18:09:30.886" v="356" actId="14100"/>
         <pc:sldMkLst>
           <pc:docMk/>
           <pc:sldMk cId="1086225493" sldId="339"/>
@@ -276,7 +291,7 @@
           </ac:picMkLst>
         </pc:picChg>
         <pc:picChg chg="add mod">
-          <ac:chgData name="Chennuboyina Siva Sruthi" userId="757dd6f6081b8728" providerId="LiveId" clId="{88ED0A32-7A4F-4E9F-9492-1FFBEDFADE5C}" dt="2026-09-10T17:25:13.432" v="274" actId="14100"/>
+          <ac:chgData name="Chennuboyina Siva Sruthi" userId="757dd6f6081b8728" providerId="LiveId" clId="{88ED0A32-7A4F-4E9F-9492-1FFBEDFADE5C}" dt="2026-09-10T18:09:30.886" v="356" actId="14100"/>
           <ac:picMkLst>
             <pc:docMk/>
             <pc:sldMk cId="1086225493" sldId="339"/>
@@ -343,6 +358,21 @@
             <pc:docMk/>
             <pc:sldMk cId="776828144" sldId="341"/>
             <ac:spMk id="3" creationId="{F5A24007-2527-0B45-264E-78B2B3E45F65}"/>
+          </ac:spMkLst>
+        </pc:spChg>
+      </pc:sldChg>
+      <pc:sldChg chg="modSp mod">
+        <pc:chgData name="Chennuboyina Siva Sruthi" userId="757dd6f6081b8728" providerId="LiveId" clId="{88ED0A32-7A4F-4E9F-9492-1FFBEDFADE5C}" dt="2026-09-10T18:08:02.838" v="325"/>
+        <pc:sldMkLst>
+          <pc:docMk/>
+          <pc:sldMk cId="3863610428" sldId="342"/>
+        </pc:sldMkLst>
+        <pc:spChg chg="mod">
+          <ac:chgData name="Chennuboyina Siva Sruthi" userId="757dd6f6081b8728" providerId="LiveId" clId="{88ED0A32-7A4F-4E9F-9492-1FFBEDFADE5C}" dt="2026-09-10T18:08:02.838" v="325"/>
+          <ac:spMkLst>
+            <pc:docMk/>
+            <pc:sldMk cId="3863610428" sldId="342"/>
+            <ac:spMk id="3" creationId="{5F0B37E4-66B1-8633-7266-68B321742757}"/>
           </ac:spMkLst>
         </pc:spChg>
       </pc:sldChg>
@@ -10862,7 +10892,7 @@
           <a:p>
             <a:r>
               <a:rPr lang="en-US" b="1" dirty="0"/>
-              <a:t>AICTE STU ID : (STU6a68e4b35bda81785259187)</a:t>
+              <a:t>AICTE STU ID : STU6a68e4b35bda81785259187</a:t>
             </a:r>
           </a:p>
         </p:txBody>
@@ -14244,7 +14274,7 @@
         <p:spPr>
           <a:xfrm>
             <a:off x="729256" y="1440320"/>
-            <a:ext cx="7232875" cy="646331"/>
+            <a:ext cx="7232875" cy="369332"/>
           </a:xfrm>
           <a:prstGeom prst="rect">
             <a:avLst/>
@@ -14259,7 +14289,7 @@
           <a:p>
             <a:r>
               <a:rPr lang="en-US" dirty="0"/>
-              <a:t>https://github.com/AswiniKumar55/-Seasonal-Agriculture-Performance-Analysis-.git</a:t>
+              <a:t>https://github.com/chennuboyinasivasruthi-ops/VOIS_Project</a:t>
             </a:r>
           </a:p>
         </p:txBody>
@@ -19813,8 +19843,8 @@
         </p:blipFill>
         <p:spPr>
           <a:xfrm>
-            <a:off x="4257652" y="1158758"/>
-            <a:ext cx="4225786" cy="2685272"/>
+            <a:off x="4345694" y="1158758"/>
+            <a:ext cx="4137744" cy="2685272"/>
           </a:xfrm>
           <a:prstGeom prst="rect">
             <a:avLst/>

</xml_diff>